<commit_message>
docs: include exported PDF presentation deck
</commit_message>
<xml_diff>
--- a/docs/Intelligent_Inventory_Presentation.pptx
+++ b/docs/Intelligent_Inventory_Presentation.pptx
@@ -5,18 +5,18 @@
     <p:sldMasterId id="2147483648" r:id="rId1"/>
   </p:sldMasterIdLst>
   <p:sldIdLst>
-    <p:sldId id="256" r:id="rId7"/>
-    <p:sldId id="257" r:id="rId8"/>
-    <p:sldId id="258" r:id="rId9"/>
-    <p:sldId id="259" r:id="rId10"/>
-    <p:sldId id="260" r:id="rId11"/>
-    <p:sldId id="261" r:id="rId12"/>
-    <p:sldId id="262" r:id="rId13"/>
-    <p:sldId id="263" r:id="rId14"/>
-    <p:sldId id="264" r:id="rId15"/>
-    <p:sldId id="265" r:id="rId16"/>
+    <p:sldId id="256" r:id="rId2"/>
+    <p:sldId id="257" r:id="rId3"/>
+    <p:sldId id="258" r:id="rId4"/>
+    <p:sldId id="259" r:id="rId5"/>
+    <p:sldId id="260" r:id="rId6"/>
+    <p:sldId id="261" r:id="rId7"/>
+    <p:sldId id="262" r:id="rId8"/>
+    <p:sldId id="263" r:id="rId9"/>
+    <p:sldId id="264" r:id="rId10"/>
+    <p:sldId id="265" r:id="rId11"/>
   </p:sldIdLst>
-  <p:sldSz cx="12191695" cy="6858000" type="screen4x3"/>
+  <p:sldSz cx="12192000" cy="6858000"/>
   <p:notesSz cx="6858000" cy="9144000"/>
   <p:defaultTextStyle>
     <a:defPPr>
@@ -113,6 +113,22 @@
       </a:defRPr>
     </a:lvl9pPr>
   </p:defaultTextStyle>
+  <p:extLst>
+    <p:ext uri="{EFAFB233-063F-42B5-8137-9DF3F51BA10A}">
+      <p15:sldGuideLst xmlns:p15="http://schemas.microsoft.com/office/powerpoint/2012/main">
+        <p15:guide id="1" orient="horz" pos="2160">
+          <p15:clr>
+            <a:srgbClr val="A4A3A4"/>
+          </p15:clr>
+        </p15:guide>
+        <p15:guide id="2" pos="2880">
+          <p15:clr>
+            <a:srgbClr val="A4A3A4"/>
+          </p15:clr>
+        </p15:guide>
+      </p15:sldGuideLst>
+    </p:ext>
+  </p:extLst>
 </p:presentation>
 </file>
 
@@ -154,10 +170,9 @@
           <a:lstStyle/>
           <a:p>
             <a:r>
-              <a:rPr lang="en-US" smtClean="0"/>
+              <a:rPr lang="en-US"/>
               <a:t>Click to edit Master title style</a:t>
             </a:r>
-            <a:endParaRPr lang="en-US"/>
           </a:p>
         </p:txBody>
       </p:sp>
@@ -273,10 +288,9 @@
           </a:lstStyle>
           <a:p>
             <a:r>
-              <a:rPr lang="en-US" smtClean="0"/>
+              <a:rPr lang="en-US"/>
               <a:t>Click to edit Master subtitle style</a:t>
             </a:r>
-            <a:endParaRPr lang="en-US"/>
           </a:p>
         </p:txBody>
       </p:sp>
@@ -297,7 +311,7 @@
           <a:p>
             <a:fld id="{5BCAD085-E8A6-8845-BD4E-CB4CCA059FC4}" type="datetimeFigureOut">
               <a:rPr lang="en-US" smtClean="0"/>
-              <a:t>1/27/13</a:t>
+              <a:t>10/19/2026</a:t>
             </a:fld>
             <a:endParaRPr lang="en-US"/>
           </a:p>
@@ -391,10 +405,9 @@
           <a:lstStyle/>
           <a:p>
             <a:r>
-              <a:rPr lang="en-US" smtClean="0"/>
+              <a:rPr lang="en-US"/>
               <a:t>Click to edit Master title style</a:t>
             </a:r>
-            <a:endParaRPr lang="en-US"/>
           </a:p>
         </p:txBody>
       </p:sp>
@@ -415,38 +428,37 @@
           <a:p>
             <a:pPr lvl="0"/>
             <a:r>
-              <a:rPr lang="en-US" smtClean="0"/>
+              <a:rPr lang="en-US"/>
               <a:t>Click to edit Master text styles</a:t>
             </a:r>
           </a:p>
           <a:p>
             <a:pPr lvl="1"/>
             <a:r>
-              <a:rPr lang="en-US" smtClean="0"/>
+              <a:rPr lang="en-US"/>
               <a:t>Second level</a:t>
             </a:r>
           </a:p>
           <a:p>
             <a:pPr lvl="2"/>
             <a:r>
-              <a:rPr lang="en-US" smtClean="0"/>
+              <a:rPr lang="en-US"/>
               <a:t>Third level</a:t>
             </a:r>
           </a:p>
           <a:p>
             <a:pPr lvl="3"/>
             <a:r>
-              <a:rPr lang="en-US" smtClean="0"/>
+              <a:rPr lang="en-US"/>
               <a:t>Fourth level</a:t>
             </a:r>
           </a:p>
           <a:p>
             <a:pPr lvl="4"/>
             <a:r>
-              <a:rPr lang="en-US" smtClean="0"/>
+              <a:rPr lang="en-US"/>
               <a:t>Fifth level</a:t>
             </a:r>
-            <a:endParaRPr lang="en-US"/>
           </a:p>
         </p:txBody>
       </p:sp>
@@ -467,7 +479,7 @@
           <a:p>
             <a:fld id="{5BCAD085-E8A6-8845-BD4E-CB4CCA059FC4}" type="datetimeFigureOut">
               <a:rPr lang="en-US" smtClean="0"/>
-              <a:t>1/27/13</a:t>
+              <a:t>10/19/2026</a:t>
             </a:fld>
             <a:endParaRPr lang="en-US"/>
           </a:p>
@@ -566,10 +578,9 @@
           <a:lstStyle/>
           <a:p>
             <a:r>
-              <a:rPr lang="en-US" smtClean="0"/>
+              <a:rPr lang="en-US"/>
               <a:t>Click to edit Master title style</a:t>
             </a:r>
-            <a:endParaRPr lang="en-US"/>
           </a:p>
         </p:txBody>
       </p:sp>
@@ -595,38 +606,37 @@
           <a:p>
             <a:pPr lvl="0"/>
             <a:r>
-              <a:rPr lang="en-US" smtClean="0"/>
+              <a:rPr lang="en-US"/>
               <a:t>Click to edit Master text styles</a:t>
             </a:r>
           </a:p>
           <a:p>
             <a:pPr lvl="1"/>
             <a:r>
-              <a:rPr lang="en-US" smtClean="0"/>
+              <a:rPr lang="en-US"/>
               <a:t>Second level</a:t>
             </a:r>
           </a:p>
           <a:p>
             <a:pPr lvl="2"/>
             <a:r>
-              <a:rPr lang="en-US" smtClean="0"/>
+              <a:rPr lang="en-US"/>
               <a:t>Third level</a:t>
             </a:r>
           </a:p>
           <a:p>
             <a:pPr lvl="3"/>
             <a:r>
-              <a:rPr lang="en-US" smtClean="0"/>
+              <a:rPr lang="en-US"/>
               <a:t>Fourth level</a:t>
             </a:r>
           </a:p>
           <a:p>
             <a:pPr lvl="4"/>
             <a:r>
-              <a:rPr lang="en-US" smtClean="0"/>
+              <a:rPr lang="en-US"/>
               <a:t>Fifth level</a:t>
             </a:r>
-            <a:endParaRPr lang="en-US"/>
           </a:p>
         </p:txBody>
       </p:sp>
@@ -647,7 +657,7 @@
           <a:p>
             <a:fld id="{5BCAD085-E8A6-8845-BD4E-CB4CCA059FC4}" type="datetimeFigureOut">
               <a:rPr lang="en-US" smtClean="0"/>
-              <a:t>1/27/13</a:t>
+              <a:t>10/19/2026</a:t>
             </a:fld>
             <a:endParaRPr lang="en-US"/>
           </a:p>
@@ -741,10 +751,9 @@
           <a:lstStyle/>
           <a:p>
             <a:r>
-              <a:rPr lang="en-US" smtClean="0"/>
+              <a:rPr lang="en-US"/>
               <a:t>Click to edit Master title style</a:t>
             </a:r>
-            <a:endParaRPr lang="en-US"/>
           </a:p>
         </p:txBody>
       </p:sp>
@@ -765,38 +774,37 @@
           <a:p>
             <a:pPr lvl="0"/>
             <a:r>
-              <a:rPr lang="en-US" smtClean="0"/>
+              <a:rPr lang="en-US"/>
               <a:t>Click to edit Master text styles</a:t>
             </a:r>
           </a:p>
           <a:p>
             <a:pPr lvl="1"/>
             <a:r>
-              <a:rPr lang="en-US" smtClean="0"/>
+              <a:rPr lang="en-US"/>
               <a:t>Second level</a:t>
             </a:r>
           </a:p>
           <a:p>
             <a:pPr lvl="2"/>
             <a:r>
-              <a:rPr lang="en-US" smtClean="0"/>
+              <a:rPr lang="en-US"/>
               <a:t>Third level</a:t>
             </a:r>
           </a:p>
           <a:p>
             <a:pPr lvl="3"/>
             <a:r>
-              <a:rPr lang="en-US" smtClean="0"/>
+              <a:rPr lang="en-US"/>
               <a:t>Fourth level</a:t>
             </a:r>
           </a:p>
           <a:p>
             <a:pPr lvl="4"/>
             <a:r>
-              <a:rPr lang="en-US" smtClean="0"/>
+              <a:rPr lang="en-US"/>
               <a:t>Fifth level</a:t>
             </a:r>
-            <a:endParaRPr lang="en-US"/>
           </a:p>
         </p:txBody>
       </p:sp>
@@ -817,7 +825,7 @@
           <a:p>
             <a:fld id="{5BCAD085-E8A6-8845-BD4E-CB4CCA059FC4}" type="datetimeFigureOut">
               <a:rPr lang="en-US" smtClean="0"/>
-              <a:t>1/27/13</a:t>
+              <a:t>10/19/2026</a:t>
             </a:fld>
             <a:endParaRPr lang="en-US"/>
           </a:p>
@@ -920,10 +928,9 @@
           </a:lstStyle>
           <a:p>
             <a:r>
-              <a:rPr lang="en-US" smtClean="0"/>
+              <a:rPr lang="en-US"/>
               <a:t>Click to edit Master title style</a:t>
             </a:r>
-            <a:endParaRPr lang="en-US"/>
           </a:p>
         </p:txBody>
       </p:sp>
@@ -1040,7 +1047,7 @@
           <a:p>
             <a:pPr lvl="0"/>
             <a:r>
-              <a:rPr lang="en-US" smtClean="0"/>
+              <a:rPr lang="en-US"/>
               <a:t>Click to edit Master text styles</a:t>
             </a:r>
           </a:p>
@@ -1063,7 +1070,7 @@
           <a:p>
             <a:fld id="{5BCAD085-E8A6-8845-BD4E-CB4CCA059FC4}" type="datetimeFigureOut">
               <a:rPr lang="en-US" smtClean="0"/>
-              <a:t>1/27/13</a:t>
+              <a:t>10/19/2026</a:t>
             </a:fld>
             <a:endParaRPr lang="en-US"/>
           </a:p>
@@ -1157,10 +1164,9 @@
           <a:lstStyle/>
           <a:p>
             <a:r>
-              <a:rPr lang="en-US" smtClean="0"/>
+              <a:rPr lang="en-US"/>
               <a:t>Click to edit Master title style</a:t>
             </a:r>
-            <a:endParaRPr lang="en-US"/>
           </a:p>
         </p:txBody>
       </p:sp>
@@ -1214,38 +1220,37 @@
           <a:p>
             <a:pPr lvl="0"/>
             <a:r>
-              <a:rPr lang="en-US" smtClean="0"/>
+              <a:rPr lang="en-US"/>
               <a:t>Click to edit Master text styles</a:t>
             </a:r>
           </a:p>
           <a:p>
             <a:pPr lvl="1"/>
             <a:r>
-              <a:rPr lang="en-US" smtClean="0"/>
+              <a:rPr lang="en-US"/>
               <a:t>Second level</a:t>
             </a:r>
           </a:p>
           <a:p>
             <a:pPr lvl="2"/>
             <a:r>
-              <a:rPr lang="en-US" smtClean="0"/>
+              <a:rPr lang="en-US"/>
               <a:t>Third level</a:t>
             </a:r>
           </a:p>
           <a:p>
             <a:pPr lvl="3"/>
             <a:r>
-              <a:rPr lang="en-US" smtClean="0"/>
+              <a:rPr lang="en-US"/>
               <a:t>Fourth level</a:t>
             </a:r>
           </a:p>
           <a:p>
             <a:pPr lvl="4"/>
             <a:r>
-              <a:rPr lang="en-US" smtClean="0"/>
+              <a:rPr lang="en-US"/>
               <a:t>Fifth level</a:t>
             </a:r>
-            <a:endParaRPr lang="en-US"/>
           </a:p>
         </p:txBody>
       </p:sp>
@@ -1299,38 +1304,37 @@
           <a:p>
             <a:pPr lvl="0"/>
             <a:r>
-              <a:rPr lang="en-US" smtClean="0"/>
+              <a:rPr lang="en-US"/>
               <a:t>Click to edit Master text styles</a:t>
             </a:r>
           </a:p>
           <a:p>
             <a:pPr lvl="1"/>
             <a:r>
-              <a:rPr lang="en-US" smtClean="0"/>
+              <a:rPr lang="en-US"/>
               <a:t>Second level</a:t>
             </a:r>
           </a:p>
           <a:p>
             <a:pPr lvl="2"/>
             <a:r>
-              <a:rPr lang="en-US" smtClean="0"/>
+              <a:rPr lang="en-US"/>
               <a:t>Third level</a:t>
             </a:r>
           </a:p>
           <a:p>
             <a:pPr lvl="3"/>
             <a:r>
-              <a:rPr lang="en-US" smtClean="0"/>
+              <a:rPr lang="en-US"/>
               <a:t>Fourth level</a:t>
             </a:r>
           </a:p>
           <a:p>
             <a:pPr lvl="4"/>
             <a:r>
-              <a:rPr lang="en-US" smtClean="0"/>
+              <a:rPr lang="en-US"/>
               <a:t>Fifth level</a:t>
             </a:r>
-            <a:endParaRPr lang="en-US"/>
           </a:p>
         </p:txBody>
       </p:sp>
@@ -1351,7 +1355,7 @@
           <a:p>
             <a:fld id="{5BCAD085-E8A6-8845-BD4E-CB4CCA059FC4}" type="datetimeFigureOut">
               <a:rPr lang="en-US" smtClean="0"/>
-              <a:t>1/27/13</a:t>
+              <a:t>10/19/2026</a:t>
             </a:fld>
             <a:endParaRPr lang="en-US"/>
           </a:p>
@@ -1449,10 +1453,9 @@
           </a:lstStyle>
           <a:p>
             <a:r>
-              <a:rPr lang="en-US" smtClean="0"/>
+              <a:rPr lang="en-US"/>
               <a:t>Click to edit Master title style</a:t>
             </a:r>
-            <a:endParaRPr lang="en-US"/>
           </a:p>
         </p:txBody>
       </p:sp>
@@ -1515,7 +1518,7 @@
           <a:p>
             <a:pPr lvl="0"/>
             <a:r>
-              <a:rPr lang="en-US" smtClean="0"/>
+              <a:rPr lang="en-US"/>
               <a:t>Click to edit Master text styles</a:t>
             </a:r>
           </a:p>
@@ -1571,38 +1574,37 @@
           <a:p>
             <a:pPr lvl="0"/>
             <a:r>
-              <a:rPr lang="en-US" smtClean="0"/>
+              <a:rPr lang="en-US"/>
               <a:t>Click to edit Master text styles</a:t>
             </a:r>
           </a:p>
           <a:p>
             <a:pPr lvl="1"/>
             <a:r>
-              <a:rPr lang="en-US" smtClean="0"/>
+              <a:rPr lang="en-US"/>
               <a:t>Second level</a:t>
             </a:r>
           </a:p>
           <a:p>
             <a:pPr lvl="2"/>
             <a:r>
-              <a:rPr lang="en-US" smtClean="0"/>
+              <a:rPr lang="en-US"/>
               <a:t>Third level</a:t>
             </a:r>
           </a:p>
           <a:p>
             <a:pPr lvl="3"/>
             <a:r>
-              <a:rPr lang="en-US" smtClean="0"/>
+              <a:rPr lang="en-US"/>
               <a:t>Fourth level</a:t>
             </a:r>
           </a:p>
           <a:p>
             <a:pPr lvl="4"/>
             <a:r>
-              <a:rPr lang="en-US" smtClean="0"/>
+              <a:rPr lang="en-US"/>
               <a:t>Fifth level</a:t>
             </a:r>
-            <a:endParaRPr lang="en-US"/>
           </a:p>
         </p:txBody>
       </p:sp>
@@ -1665,7 +1667,7 @@
           <a:p>
             <a:pPr lvl="0"/>
             <a:r>
-              <a:rPr lang="en-US" smtClean="0"/>
+              <a:rPr lang="en-US"/>
               <a:t>Click to edit Master text styles</a:t>
             </a:r>
           </a:p>
@@ -1721,38 +1723,37 @@
           <a:p>
             <a:pPr lvl="0"/>
             <a:r>
-              <a:rPr lang="en-US" smtClean="0"/>
+              <a:rPr lang="en-US"/>
               <a:t>Click to edit Master text styles</a:t>
             </a:r>
           </a:p>
           <a:p>
             <a:pPr lvl="1"/>
             <a:r>
-              <a:rPr lang="en-US" smtClean="0"/>
+              <a:rPr lang="en-US"/>
               <a:t>Second level</a:t>
             </a:r>
           </a:p>
           <a:p>
             <a:pPr lvl="2"/>
             <a:r>
-              <a:rPr lang="en-US" smtClean="0"/>
+              <a:rPr lang="en-US"/>
               <a:t>Third level</a:t>
             </a:r>
           </a:p>
           <a:p>
             <a:pPr lvl="3"/>
             <a:r>
-              <a:rPr lang="en-US" smtClean="0"/>
+              <a:rPr lang="en-US"/>
               <a:t>Fourth level</a:t>
             </a:r>
           </a:p>
           <a:p>
             <a:pPr lvl="4"/>
             <a:r>
-              <a:rPr lang="en-US" smtClean="0"/>
+              <a:rPr lang="en-US"/>
               <a:t>Fifth level</a:t>
             </a:r>
-            <a:endParaRPr lang="en-US"/>
           </a:p>
         </p:txBody>
       </p:sp>
@@ -1773,7 +1774,7 @@
           <a:p>
             <a:fld id="{5BCAD085-E8A6-8845-BD4E-CB4CCA059FC4}" type="datetimeFigureOut">
               <a:rPr lang="en-US" smtClean="0"/>
-              <a:t>1/27/13</a:t>
+              <a:t>10/19/2026</a:t>
             </a:fld>
             <a:endParaRPr lang="en-US"/>
           </a:p>
@@ -1867,10 +1868,9 @@
           <a:lstStyle/>
           <a:p>
             <a:r>
-              <a:rPr lang="en-US" smtClean="0"/>
+              <a:rPr lang="en-US"/>
               <a:t>Click to edit Master title style</a:t>
             </a:r>
-            <a:endParaRPr lang="en-US"/>
           </a:p>
         </p:txBody>
       </p:sp>
@@ -1891,7 +1891,7 @@
           <a:p>
             <a:fld id="{5BCAD085-E8A6-8845-BD4E-CB4CCA059FC4}" type="datetimeFigureOut">
               <a:rPr lang="en-US" smtClean="0"/>
-              <a:t>1/27/13</a:t>
+              <a:t>10/19/2026</a:t>
             </a:fld>
             <a:endParaRPr lang="en-US"/>
           </a:p>
@@ -1986,7 +1986,7 @@
           <a:p>
             <a:fld id="{5BCAD085-E8A6-8845-BD4E-CB4CCA059FC4}" type="datetimeFigureOut">
               <a:rPr lang="en-US" smtClean="0"/>
-              <a:t>1/27/13</a:t>
+              <a:t>10/19/2026</a:t>
             </a:fld>
             <a:endParaRPr lang="en-US"/>
           </a:p>
@@ -2089,10 +2089,9 @@
           </a:lstStyle>
           <a:p>
             <a:r>
-              <a:rPr lang="en-US" smtClean="0"/>
+              <a:rPr lang="en-US"/>
               <a:t>Click to edit Master title style</a:t>
             </a:r>
-            <a:endParaRPr lang="en-US"/>
           </a:p>
         </p:txBody>
       </p:sp>
@@ -2146,38 +2145,37 @@
           <a:p>
             <a:pPr lvl="0"/>
             <a:r>
-              <a:rPr lang="en-US" smtClean="0"/>
+              <a:rPr lang="en-US"/>
               <a:t>Click to edit Master text styles</a:t>
             </a:r>
           </a:p>
           <a:p>
             <a:pPr lvl="1"/>
             <a:r>
-              <a:rPr lang="en-US" smtClean="0"/>
+              <a:rPr lang="en-US"/>
               <a:t>Second level</a:t>
             </a:r>
           </a:p>
           <a:p>
             <a:pPr lvl="2"/>
             <a:r>
-              <a:rPr lang="en-US" smtClean="0"/>
+              <a:rPr lang="en-US"/>
               <a:t>Third level</a:t>
             </a:r>
           </a:p>
           <a:p>
             <a:pPr lvl="3"/>
             <a:r>
-              <a:rPr lang="en-US" smtClean="0"/>
+              <a:rPr lang="en-US"/>
               <a:t>Fourth level</a:t>
             </a:r>
           </a:p>
           <a:p>
             <a:pPr lvl="4"/>
             <a:r>
-              <a:rPr lang="en-US" smtClean="0"/>
+              <a:rPr lang="en-US"/>
               <a:t>Fifth level</a:t>
             </a:r>
-            <a:endParaRPr lang="en-US"/>
           </a:p>
         </p:txBody>
       </p:sp>
@@ -2240,7 +2238,7 @@
           <a:p>
             <a:pPr lvl="0"/>
             <a:r>
-              <a:rPr lang="en-US" smtClean="0"/>
+              <a:rPr lang="en-US"/>
               <a:t>Click to edit Master text styles</a:t>
             </a:r>
           </a:p>
@@ -2263,7 +2261,7 @@
           <a:p>
             <a:fld id="{5BCAD085-E8A6-8845-BD4E-CB4CCA059FC4}" type="datetimeFigureOut">
               <a:rPr lang="en-US" smtClean="0"/>
-              <a:t>1/27/13</a:t>
+              <a:t>10/19/2026</a:t>
             </a:fld>
             <a:endParaRPr lang="en-US"/>
           </a:p>
@@ -2366,10 +2364,9 @@
           </a:lstStyle>
           <a:p>
             <a:r>
-              <a:rPr lang="en-US" smtClean="0"/>
+              <a:rPr lang="en-US"/>
               <a:t>Click to edit Master title style</a:t>
             </a:r>
-            <a:endParaRPr lang="en-US"/>
           </a:p>
         </p:txBody>
       </p:sp>
@@ -2493,7 +2490,7 @@
           <a:p>
             <a:pPr lvl="0"/>
             <a:r>
-              <a:rPr lang="en-US" smtClean="0"/>
+              <a:rPr lang="en-US"/>
               <a:t>Click to edit Master text styles</a:t>
             </a:r>
           </a:p>
@@ -2516,7 +2513,7 @@
           <a:p>
             <a:fld id="{5BCAD085-E8A6-8845-BD4E-CB4CCA059FC4}" type="datetimeFigureOut">
               <a:rPr lang="en-US" smtClean="0"/>
-              <a:t>1/27/13</a:t>
+              <a:t>10/19/2026</a:t>
             </a:fld>
             <a:endParaRPr lang="en-US"/>
           </a:p>
@@ -2625,10 +2622,9 @@
           <a:lstStyle/>
           <a:p>
             <a:r>
-              <a:rPr lang="en-US" smtClean="0"/>
+              <a:rPr lang="en-US"/>
               <a:t>Click to edit Master title style</a:t>
             </a:r>
-            <a:endParaRPr lang="en-US"/>
           </a:p>
         </p:txBody>
       </p:sp>
@@ -2659,38 +2655,37 @@
           <a:p>
             <a:pPr lvl="0"/>
             <a:r>
-              <a:rPr lang="en-US" smtClean="0"/>
+              <a:rPr lang="en-US"/>
               <a:t>Click to edit Master text styles</a:t>
             </a:r>
           </a:p>
           <a:p>
             <a:pPr lvl="1"/>
             <a:r>
-              <a:rPr lang="en-US" smtClean="0"/>
+              <a:rPr lang="en-US"/>
               <a:t>Second level</a:t>
             </a:r>
           </a:p>
           <a:p>
             <a:pPr lvl="2"/>
             <a:r>
-              <a:rPr lang="en-US" smtClean="0"/>
+              <a:rPr lang="en-US"/>
               <a:t>Third level</a:t>
             </a:r>
           </a:p>
           <a:p>
             <a:pPr lvl="3"/>
             <a:r>
-              <a:rPr lang="en-US" smtClean="0"/>
+              <a:rPr lang="en-US"/>
               <a:t>Fourth level</a:t>
             </a:r>
           </a:p>
           <a:p>
             <a:pPr lvl="4"/>
             <a:r>
-              <a:rPr lang="en-US" smtClean="0"/>
+              <a:rPr lang="en-US"/>
               <a:t>Fifth level</a:t>
             </a:r>
-            <a:endParaRPr lang="en-US"/>
           </a:p>
         </p:txBody>
       </p:sp>
@@ -2729,7 +2724,7 @@
           <a:p>
             <a:fld id="{5BCAD085-E8A6-8845-BD4E-CB4CCA059FC4}" type="datetimeFigureOut">
               <a:rPr lang="en-US" smtClean="0"/>
-              <a:t>1/27/13</a:t>
+              <a:t>10/19/2026</a:t>
             </a:fld>
             <a:endParaRPr lang="en-US"/>
           </a:p>
@@ -3088,7 +3083,7 @@
 </file>
 
 <file path=ppt/slides/slide1.xml><?xml version="1.0" encoding="utf-8"?>
-<p:sld xmlns:a="http://schemas.openxmlformats.org/drawingml/2006/main" xmlns:p="http://schemas.openxmlformats.org/presentationml/2006/main" xmlns:r="http://schemas.openxmlformats.org/officeDocument/2006/relationships">
+<p:sld xmlns:a="http://schemas.openxmlformats.org/drawingml/2006/main" xmlns:r="http://schemas.openxmlformats.org/officeDocument/2006/relationships" xmlns:p="http://schemas.openxmlformats.org/presentationml/2006/main">
   <p:cSld>
     <p:spTree>
       <p:nvGrpSpPr>
@@ -3096,7 +3091,14 @@
         <p:cNvGrpSpPr/>
         <p:nvPr/>
       </p:nvGrpSpPr>
-      <p:grpSpPr/>
+      <p:grpSpPr>
+        <a:xfrm>
+          <a:off x="0" y="0"/>
+          <a:ext cx="0" cy="0"/>
+          <a:chOff x="0" y="0"/>
+          <a:chExt cx="0" cy="0"/>
+        </a:xfrm>
+      </p:grpSpPr>
       <p:sp>
         <p:nvSpPr>
           <p:cNvPr id="2" name="Rectangle 1"/>
@@ -3105,7 +3107,7 @@
         </p:nvSpPr>
         <p:spPr>
           <a:xfrm>
-            <a:off x="0" y="0"/>
+            <a:off x="17252" y="17252"/>
             <a:ext cx="12191695" cy="6858000"/>
           </a:xfrm>
           <a:prstGeom prst="rect">
@@ -3137,6 +3139,7 @@
           <a:lstStyle/>
           <a:p>
             <a:pPr algn="ctr"/>
+            <a:endParaRPr/>
           </a:p>
         </p:txBody>
       </p:sp>
@@ -3190,7 +3193,8 @@
               </a:defRPr>
             </a:pPr>
             <a:r>
-              <a:t>CAPSTONE PROJECT  •  CSE494 COMPUTER SCIENCE</a:t>
+              <a:rPr dirty="0"/>
+              <a:t> CSE494 COMPUTER SCIENCE</a:t>
             </a:r>
           </a:p>
         </p:txBody>
@@ -3203,7 +3207,7 @@
         </p:nvSpPr>
         <p:spPr>
           <a:xfrm>
-            <a:off x="731520" y="1280160"/>
+            <a:off x="731520" y="1288786"/>
             <a:ext cx="10728655" cy="1371600"/>
           </a:xfrm>
           <a:prstGeom prst="rect">
@@ -3309,7 +3313,7 @@
           </a:fontRef>
         </p:style>
         <p:txBody>
-          <a:bodyPr rtlCol="0" anchor="ctr" wrap="square"/>
+          <a:bodyPr wrap="square" rtlCol="0" anchor="ctr"/>
           <a:lstStyle/>
           <a:p>
             <a:pPr algn="ctr">
@@ -3321,6 +3325,7 @@
               </a:defRPr>
             </a:pPr>
             <a:r>
+              <a:rPr dirty="0"/>
               <a:t>PROJECT METADATA &amp; ARCHITECTURE OVERVIEW</a:t>
             </a:r>
           </a:p>
@@ -3331,7 +3336,7 @@
               </a:spcBef>
             </a:pPr>
             <a:r>
-              <a:rPr b="1">
+              <a:rPr b="1" dirty="0">
                 <a:solidFill>
                   <a:srgbClr val="0F172A"/>
                 </a:solidFill>
@@ -3339,15 +3344,23 @@
               <a:t>Lead Developer: </a:t>
             </a:r>
             <a:r>
-              <a:rPr>
+              <a:rPr lang="en-IN" b="1" dirty="0">
                 <a:solidFill>
                   <a:srgbClr val="334155"/>
                 </a:solidFill>
               </a:rPr>
-              <a:t>Arush Rai (arushrai007)   |   </a:t>
-            </a:r>
-            <a:r>
-              <a:rPr b="1">
+              <a:t>Suresh Bishnoi</a:t>
+            </a:r>
+            <a:r>
+              <a:rPr dirty="0">
+                <a:solidFill>
+                  <a:srgbClr val="334155"/>
+                </a:solidFill>
+              </a:rPr>
+              <a:t>   |   </a:t>
+            </a:r>
+            <a:r>
+              <a:rPr b="1" dirty="0">
                 <a:solidFill>
                   <a:srgbClr val="0F172A"/>
                 </a:solidFill>
@@ -3355,12 +3368,44 @@
               <a:t>Full Stack: </a:t>
             </a:r>
             <a:r>
-              <a:rPr>
+              <a:rPr dirty="0">
                 <a:solidFill>
                   <a:srgbClr val="10B981"/>
                 </a:solidFill>
               </a:rPr>
-              <a:t>Python 3.12+ (FastAPI) • PyMongo • Scikit-Learn • React 18 + Vite • Tailwind CSS • MongoDB Atlas</a:t>
+              <a:t>Python 3.12+ (</a:t>
+            </a:r>
+            <a:r>
+              <a:rPr dirty="0" err="1">
+                <a:solidFill>
+                  <a:srgbClr val="10B981"/>
+                </a:solidFill>
+              </a:rPr>
+              <a:t>FastAPI</a:t>
+            </a:r>
+            <a:r>
+              <a:rPr dirty="0">
+                <a:solidFill>
+                  <a:srgbClr val="10B981"/>
+                </a:solidFill>
+              </a:rPr>
+              <a:t>) • </a:t>
+            </a:r>
+            <a:r>
+              <a:rPr dirty="0" err="1">
+                <a:solidFill>
+                  <a:srgbClr val="10B981"/>
+                </a:solidFill>
+              </a:rPr>
+              <a:t>PyMongo</a:t>
+            </a:r>
+            <a:r>
+              <a:rPr dirty="0">
+                <a:solidFill>
+                  <a:srgbClr val="10B981"/>
+                </a:solidFill>
+              </a:rPr>
+              <a:t> • Scikit-Learn • React 18 + Vite • Tailwind CSS • MongoDB Atlas</a:t>
             </a:r>
           </a:p>
         </p:txBody>
@@ -3407,6 +3452,7 @@
           <a:lstStyle/>
           <a:p>
             <a:pPr algn="ctr"/>
+            <a:endParaRPr/>
           </a:p>
         </p:txBody>
       </p:sp>
@@ -3450,6 +3496,7 @@
           <a:lstStyle/>
           <a:p>
             <a:pPr algn="ctr"/>
+            <a:endParaRPr/>
           </a:p>
         </p:txBody>
       </p:sp>
@@ -3560,6 +3607,7 @@
           <a:lstStyle/>
           <a:p>
             <a:pPr algn="ctr"/>
+            <a:endParaRPr/>
           </a:p>
         </p:txBody>
       </p:sp>
@@ -3603,6 +3651,7 @@
           <a:lstStyle/>
           <a:p>
             <a:pPr algn="ctr"/>
+            <a:endParaRPr/>
           </a:p>
         </p:txBody>
       </p:sp>
@@ -3713,6 +3762,7 @@
           <a:lstStyle/>
           <a:p>
             <a:pPr algn="ctr"/>
+            <a:endParaRPr/>
           </a:p>
         </p:txBody>
       </p:sp>
@@ -3756,6 +3806,7 @@
           <a:lstStyle/>
           <a:p>
             <a:pPr algn="ctr"/>
+            <a:endParaRPr/>
           </a:p>
         </p:txBody>
       </p:sp>
@@ -3866,6 +3917,7 @@
           <a:lstStyle/>
           <a:p>
             <a:pPr algn="ctr"/>
+            <a:endParaRPr/>
           </a:p>
         </p:txBody>
       </p:sp>
@@ -3909,6 +3961,7 @@
           <a:lstStyle/>
           <a:p>
             <a:pPr algn="ctr"/>
+            <a:endParaRPr/>
           </a:p>
         </p:txBody>
       </p:sp>
@@ -4017,6 +4070,7 @@
           <a:lstStyle/>
           <a:p>
             <a:pPr algn="ctr"/>
+            <a:endParaRPr/>
           </a:p>
         </p:txBody>
       </p:sp>
@@ -4101,7 +4155,7 @@
 </file>
 
 <file path=ppt/slides/slide10.xml><?xml version="1.0" encoding="utf-8"?>
-<p:sld xmlns:a="http://schemas.openxmlformats.org/drawingml/2006/main" xmlns:p="http://schemas.openxmlformats.org/presentationml/2006/main" xmlns:r="http://schemas.openxmlformats.org/officeDocument/2006/relationships">
+<p:sld xmlns:a="http://schemas.openxmlformats.org/drawingml/2006/main" xmlns:r="http://schemas.openxmlformats.org/officeDocument/2006/relationships" xmlns:p="http://schemas.openxmlformats.org/presentationml/2006/main">
   <p:cSld>
     <p:spTree>
       <p:nvGrpSpPr>
@@ -4109,7 +4163,14 @@
         <p:cNvGrpSpPr/>
         <p:nvPr/>
       </p:nvGrpSpPr>
-      <p:grpSpPr/>
+      <p:grpSpPr>
+        <a:xfrm>
+          <a:off x="0" y="0"/>
+          <a:ext cx="0" cy="0"/>
+          <a:chOff x="0" y="0"/>
+          <a:chExt cx="0" cy="0"/>
+        </a:xfrm>
+      </p:grpSpPr>
       <p:sp>
         <p:nvSpPr>
           <p:cNvPr id="2" name="Rectangle 1"/>
@@ -4150,6 +4211,7 @@
           <a:lstStyle/>
           <a:p>
             <a:pPr algn="ctr"/>
+            <a:endParaRPr/>
           </a:p>
         </p:txBody>
       </p:sp>
@@ -4303,6 +4365,7 @@
           <a:lstStyle/>
           <a:p>
             <a:pPr algn="ctr"/>
+            <a:endParaRPr/>
           </a:p>
         </p:txBody>
       </p:sp>
@@ -4346,6 +4409,7 @@
           <a:lstStyle/>
           <a:p>
             <a:pPr algn="ctr"/>
+            <a:endParaRPr/>
           </a:p>
         </p:txBody>
       </p:sp>
@@ -4456,6 +4520,7 @@
           <a:lstStyle/>
           <a:p>
             <a:pPr algn="ctr"/>
+            <a:endParaRPr/>
           </a:p>
         </p:txBody>
       </p:sp>
@@ -4499,6 +4564,7 @@
           <a:lstStyle/>
           <a:p>
             <a:pPr algn="ctr"/>
+            <a:endParaRPr/>
           </a:p>
         </p:txBody>
       </p:sp>
@@ -4609,6 +4675,7 @@
           <a:lstStyle/>
           <a:p>
             <a:pPr algn="ctr"/>
+            <a:endParaRPr/>
           </a:p>
         </p:txBody>
       </p:sp>
@@ -4652,6 +4719,7 @@
           <a:lstStyle/>
           <a:p>
             <a:pPr algn="ctr"/>
+            <a:endParaRPr/>
           </a:p>
         </p:txBody>
       </p:sp>
@@ -4762,6 +4830,7 @@
           <a:lstStyle/>
           <a:p>
             <a:pPr algn="ctr"/>
+            <a:endParaRPr/>
           </a:p>
         </p:txBody>
       </p:sp>
@@ -4805,6 +4874,7 @@
           <a:lstStyle/>
           <a:p>
             <a:pPr algn="ctr"/>
+            <a:endParaRPr/>
           </a:p>
         </p:txBody>
       </p:sp>
@@ -5022,6 +5092,7 @@
           <a:lstStyle/>
           <a:p>
             <a:pPr algn="ctr"/>
+            <a:endParaRPr/>
           </a:p>
         </p:txBody>
       </p:sp>
@@ -5065,6 +5136,7 @@
           <a:lstStyle/>
           <a:p>
             <a:pPr algn="ctr"/>
+            <a:endParaRPr/>
           </a:p>
         </p:txBody>
       </p:sp>
@@ -5280,6 +5352,7 @@
           <a:lstStyle/>
           <a:p>
             <a:pPr algn="ctr"/>
+            <a:endParaRPr/>
           </a:p>
         </p:txBody>
       </p:sp>
@@ -5364,7 +5437,7 @@
 </file>
 
 <file path=ppt/slides/slide2.xml><?xml version="1.0" encoding="utf-8"?>
-<p:sld xmlns:a="http://schemas.openxmlformats.org/drawingml/2006/main" xmlns:p="http://schemas.openxmlformats.org/presentationml/2006/main" xmlns:r="http://schemas.openxmlformats.org/officeDocument/2006/relationships">
+<p:sld xmlns:a="http://schemas.openxmlformats.org/drawingml/2006/main" xmlns:r="http://schemas.openxmlformats.org/officeDocument/2006/relationships" xmlns:p="http://schemas.openxmlformats.org/presentationml/2006/main">
   <p:cSld>
     <p:spTree>
       <p:nvGrpSpPr>
@@ -5372,7 +5445,14 @@
         <p:cNvGrpSpPr/>
         <p:nvPr/>
       </p:nvGrpSpPr>
-      <p:grpSpPr/>
+      <p:grpSpPr>
+        <a:xfrm>
+          <a:off x="0" y="0"/>
+          <a:ext cx="0" cy="0"/>
+          <a:chOff x="0" y="0"/>
+          <a:chExt cx="0" cy="0"/>
+        </a:xfrm>
+      </p:grpSpPr>
       <p:sp>
         <p:nvSpPr>
           <p:cNvPr id="2" name="Rectangle 1"/>
@@ -5413,6 +5493,7 @@
           <a:lstStyle/>
           <a:p>
             <a:pPr algn="ctr"/>
+            <a:endParaRPr/>
           </a:p>
         </p:txBody>
       </p:sp>
@@ -5566,6 +5647,7 @@
           <a:lstStyle/>
           <a:p>
             <a:pPr algn="ctr"/>
+            <a:endParaRPr/>
           </a:p>
         </p:txBody>
       </p:sp>
@@ -5609,6 +5691,7 @@
           <a:lstStyle/>
           <a:p>
             <a:pPr algn="ctr"/>
+            <a:endParaRPr/>
           </a:p>
         </p:txBody>
       </p:sp>
@@ -5719,6 +5802,7 @@
           <a:lstStyle/>
           <a:p>
             <a:pPr algn="ctr"/>
+            <a:endParaRPr/>
           </a:p>
         </p:txBody>
       </p:sp>
@@ -5762,6 +5846,7 @@
           <a:lstStyle/>
           <a:p>
             <a:pPr algn="ctr"/>
+            <a:endParaRPr/>
           </a:p>
         </p:txBody>
       </p:sp>
@@ -5872,6 +5957,7 @@
           <a:lstStyle/>
           <a:p>
             <a:pPr algn="ctr"/>
+            <a:endParaRPr/>
           </a:p>
         </p:txBody>
       </p:sp>
@@ -5915,6 +6001,7 @@
           <a:lstStyle/>
           <a:p>
             <a:pPr algn="ctr"/>
+            <a:endParaRPr/>
           </a:p>
         </p:txBody>
       </p:sp>
@@ -6025,6 +6112,7 @@
           <a:lstStyle/>
           <a:p>
             <a:pPr algn="ctr"/>
+            <a:endParaRPr/>
           </a:p>
         </p:txBody>
       </p:sp>
@@ -6068,6 +6156,7 @@
           <a:lstStyle/>
           <a:p>
             <a:pPr algn="ctr"/>
+            <a:endParaRPr/>
           </a:p>
         </p:txBody>
       </p:sp>
@@ -6285,6 +6374,7 @@
           <a:lstStyle/>
           <a:p>
             <a:pPr algn="ctr"/>
+            <a:endParaRPr/>
           </a:p>
         </p:txBody>
       </p:sp>
@@ -6328,6 +6418,7 @@
           <a:lstStyle/>
           <a:p>
             <a:pPr algn="ctr"/>
+            <a:endParaRPr/>
           </a:p>
         </p:txBody>
       </p:sp>
@@ -6543,6 +6634,7 @@
           <a:lstStyle/>
           <a:p>
             <a:pPr algn="ctr"/>
+            <a:endParaRPr/>
           </a:p>
         </p:txBody>
       </p:sp>
@@ -6627,7 +6719,7 @@
 </file>
 
 <file path=ppt/slides/slide3.xml><?xml version="1.0" encoding="utf-8"?>
-<p:sld xmlns:a="http://schemas.openxmlformats.org/drawingml/2006/main" xmlns:p="http://schemas.openxmlformats.org/presentationml/2006/main" xmlns:r="http://schemas.openxmlformats.org/officeDocument/2006/relationships">
+<p:sld xmlns:a="http://schemas.openxmlformats.org/drawingml/2006/main" xmlns:r="http://schemas.openxmlformats.org/officeDocument/2006/relationships" xmlns:p="http://schemas.openxmlformats.org/presentationml/2006/main">
   <p:cSld>
     <p:spTree>
       <p:nvGrpSpPr>
@@ -6635,7 +6727,14 @@
         <p:cNvGrpSpPr/>
         <p:nvPr/>
       </p:nvGrpSpPr>
-      <p:grpSpPr/>
+      <p:grpSpPr>
+        <a:xfrm>
+          <a:off x="0" y="0"/>
+          <a:ext cx="0" cy="0"/>
+          <a:chOff x="0" y="0"/>
+          <a:chExt cx="0" cy="0"/>
+        </a:xfrm>
+      </p:grpSpPr>
       <p:sp>
         <p:nvSpPr>
           <p:cNvPr id="2" name="Rectangle 1"/>
@@ -6676,6 +6775,7 @@
           <a:lstStyle/>
           <a:p>
             <a:pPr algn="ctr"/>
+            <a:endParaRPr/>
           </a:p>
         </p:txBody>
       </p:sp>
@@ -6829,6 +6929,7 @@
           <a:lstStyle/>
           <a:p>
             <a:pPr algn="ctr"/>
+            <a:endParaRPr/>
           </a:p>
         </p:txBody>
       </p:sp>
@@ -6872,6 +6973,7 @@
           <a:lstStyle/>
           <a:p>
             <a:pPr algn="ctr"/>
+            <a:endParaRPr/>
           </a:p>
         </p:txBody>
       </p:sp>
@@ -7164,6 +7266,7 @@
           <a:lstStyle/>
           <a:p>
             <a:pPr algn="ctr"/>
+            <a:endParaRPr/>
           </a:p>
         </p:txBody>
       </p:sp>
@@ -7207,6 +7310,7 @@
           <a:lstStyle/>
           <a:p>
             <a:pPr algn="ctr"/>
+            <a:endParaRPr/>
           </a:p>
         </p:txBody>
       </p:sp>
@@ -7499,6 +7603,7 @@
           <a:lstStyle/>
           <a:p>
             <a:pPr algn="ctr"/>
+            <a:endParaRPr/>
           </a:p>
         </p:txBody>
       </p:sp>
@@ -7542,6 +7647,7 @@
           <a:lstStyle/>
           <a:p>
             <a:pPr algn="ctr"/>
+            <a:endParaRPr/>
           </a:p>
         </p:txBody>
       </p:sp>
@@ -7832,6 +7938,7 @@
           <a:lstStyle/>
           <a:p>
             <a:pPr algn="ctr"/>
+            <a:endParaRPr/>
           </a:p>
         </p:txBody>
       </p:sp>
@@ -7916,7 +8023,7 @@
 </file>
 
 <file path=ppt/slides/slide4.xml><?xml version="1.0" encoding="utf-8"?>
-<p:sld xmlns:a="http://schemas.openxmlformats.org/drawingml/2006/main" xmlns:p="http://schemas.openxmlformats.org/presentationml/2006/main" xmlns:r="http://schemas.openxmlformats.org/officeDocument/2006/relationships">
+<p:sld xmlns:a="http://schemas.openxmlformats.org/drawingml/2006/main" xmlns:r="http://schemas.openxmlformats.org/officeDocument/2006/relationships" xmlns:p="http://schemas.openxmlformats.org/presentationml/2006/main">
   <p:cSld>
     <p:spTree>
       <p:nvGrpSpPr>
@@ -7924,7 +8031,14 @@
         <p:cNvGrpSpPr/>
         <p:nvPr/>
       </p:nvGrpSpPr>
-      <p:grpSpPr/>
+      <p:grpSpPr>
+        <a:xfrm>
+          <a:off x="0" y="0"/>
+          <a:ext cx="0" cy="0"/>
+          <a:chOff x="0" y="0"/>
+          <a:chExt cx="0" cy="0"/>
+        </a:xfrm>
+      </p:grpSpPr>
       <p:sp>
         <p:nvSpPr>
           <p:cNvPr id="2" name="Rectangle 1"/>
@@ -7965,6 +8079,7 @@
           <a:lstStyle/>
           <a:p>
             <a:pPr algn="ctr"/>
+            <a:endParaRPr/>
           </a:p>
         </p:txBody>
       </p:sp>
@@ -8118,6 +8233,7 @@
           <a:lstStyle/>
           <a:p>
             <a:pPr algn="ctr"/>
+            <a:endParaRPr/>
           </a:p>
         </p:txBody>
       </p:sp>
@@ -8161,6 +8277,7 @@
           <a:lstStyle/>
           <a:p>
             <a:pPr algn="ctr"/>
+            <a:endParaRPr/>
           </a:p>
         </p:txBody>
       </p:sp>
@@ -8328,6 +8445,7 @@
           <a:lstStyle/>
           <a:p>
             <a:pPr algn="ctr"/>
+            <a:endParaRPr/>
           </a:p>
         </p:txBody>
       </p:sp>
@@ -8371,6 +8489,7 @@
           <a:lstStyle/>
           <a:p>
             <a:pPr algn="ctr"/>
+            <a:endParaRPr/>
           </a:p>
         </p:txBody>
       </p:sp>
@@ -8563,6 +8682,7 @@
           <a:lstStyle/>
           <a:p>
             <a:pPr algn="ctr"/>
+            <a:endParaRPr/>
           </a:p>
         </p:txBody>
       </p:sp>
@@ -8606,6 +8726,7 @@
           <a:lstStyle/>
           <a:p>
             <a:pPr algn="ctr"/>
+            <a:endParaRPr/>
           </a:p>
         </p:txBody>
       </p:sp>
@@ -8773,6 +8894,7 @@
           <a:lstStyle/>
           <a:p>
             <a:pPr algn="ctr"/>
+            <a:endParaRPr/>
           </a:p>
         </p:txBody>
       </p:sp>
@@ -8816,6 +8938,7 @@
           <a:lstStyle/>
           <a:p>
             <a:pPr algn="ctr"/>
+            <a:endParaRPr/>
           </a:p>
         </p:txBody>
       </p:sp>
@@ -8981,6 +9104,7 @@
           <a:lstStyle/>
           <a:p>
             <a:pPr algn="ctr"/>
+            <a:endParaRPr/>
           </a:p>
         </p:txBody>
       </p:sp>
@@ -9065,7 +9189,7 @@
 </file>
 
 <file path=ppt/slides/slide5.xml><?xml version="1.0" encoding="utf-8"?>
-<p:sld xmlns:a="http://schemas.openxmlformats.org/drawingml/2006/main" xmlns:p="http://schemas.openxmlformats.org/presentationml/2006/main" xmlns:r="http://schemas.openxmlformats.org/officeDocument/2006/relationships">
+<p:sld xmlns:a="http://schemas.openxmlformats.org/drawingml/2006/main" xmlns:r="http://schemas.openxmlformats.org/officeDocument/2006/relationships" xmlns:p="http://schemas.openxmlformats.org/presentationml/2006/main">
   <p:cSld>
     <p:spTree>
       <p:nvGrpSpPr>
@@ -9073,7 +9197,14 @@
         <p:cNvGrpSpPr/>
         <p:nvPr/>
       </p:nvGrpSpPr>
-      <p:grpSpPr/>
+      <p:grpSpPr>
+        <a:xfrm>
+          <a:off x="0" y="0"/>
+          <a:ext cx="0" cy="0"/>
+          <a:chOff x="0" y="0"/>
+          <a:chExt cx="0" cy="0"/>
+        </a:xfrm>
+      </p:grpSpPr>
       <p:sp>
         <p:nvSpPr>
           <p:cNvPr id="2" name="Rectangle 1"/>
@@ -9114,6 +9245,7 @@
           <a:lstStyle/>
           <a:p>
             <a:pPr algn="ctr"/>
+            <a:endParaRPr/>
           </a:p>
         </p:txBody>
       </p:sp>
@@ -9267,6 +9399,7 @@
           <a:lstStyle/>
           <a:p>
             <a:pPr algn="ctr"/>
+            <a:endParaRPr/>
           </a:p>
         </p:txBody>
       </p:sp>
@@ -9310,6 +9443,7 @@
           <a:lstStyle/>
           <a:p>
             <a:pPr algn="ctr"/>
+            <a:endParaRPr/>
           </a:p>
         </p:txBody>
       </p:sp>
@@ -9420,6 +9554,7 @@
           <a:lstStyle/>
           <a:p>
             <a:pPr algn="ctr"/>
+            <a:endParaRPr/>
           </a:p>
         </p:txBody>
       </p:sp>
@@ -9463,6 +9598,7 @@
           <a:lstStyle/>
           <a:p>
             <a:pPr algn="ctr"/>
+            <a:endParaRPr/>
           </a:p>
         </p:txBody>
       </p:sp>
@@ -9573,6 +9709,7 @@
           <a:lstStyle/>
           <a:p>
             <a:pPr algn="ctr"/>
+            <a:endParaRPr/>
           </a:p>
         </p:txBody>
       </p:sp>
@@ -9616,6 +9753,7 @@
           <a:lstStyle/>
           <a:p>
             <a:pPr algn="ctr"/>
+            <a:endParaRPr/>
           </a:p>
         </p:txBody>
       </p:sp>
@@ -9726,6 +9864,7 @@
           <a:lstStyle/>
           <a:p>
             <a:pPr algn="ctr"/>
+            <a:endParaRPr/>
           </a:p>
         </p:txBody>
       </p:sp>
@@ -9769,6 +9908,7 @@
           <a:lstStyle/>
           <a:p>
             <a:pPr algn="ctr"/>
+            <a:endParaRPr/>
           </a:p>
         </p:txBody>
       </p:sp>
@@ -9879,6 +10019,7 @@
           <a:lstStyle/>
           <a:p>
             <a:pPr algn="ctr"/>
+            <a:endParaRPr/>
           </a:p>
         </p:txBody>
       </p:sp>
@@ -9922,6 +10063,7 @@
           <a:lstStyle/>
           <a:p>
             <a:pPr algn="ctr"/>
+            <a:endParaRPr/>
           </a:p>
         </p:txBody>
       </p:sp>
@@ -10164,6 +10306,7 @@
           <a:lstStyle/>
           <a:p>
             <a:pPr algn="ctr"/>
+            <a:endParaRPr/>
           </a:p>
         </p:txBody>
       </p:sp>
@@ -10207,6 +10350,7 @@
           <a:lstStyle/>
           <a:p>
             <a:pPr algn="ctr"/>
+            <a:endParaRPr/>
           </a:p>
         </p:txBody>
       </p:sp>
@@ -10422,6 +10566,7 @@
           <a:lstStyle/>
           <a:p>
             <a:pPr algn="ctr"/>
+            <a:endParaRPr/>
           </a:p>
         </p:txBody>
       </p:sp>
@@ -10506,7 +10651,7 @@
 </file>
 
 <file path=ppt/slides/slide6.xml><?xml version="1.0" encoding="utf-8"?>
-<p:sld xmlns:a="http://schemas.openxmlformats.org/drawingml/2006/main" xmlns:p="http://schemas.openxmlformats.org/presentationml/2006/main" xmlns:r="http://schemas.openxmlformats.org/officeDocument/2006/relationships">
+<p:sld xmlns:a="http://schemas.openxmlformats.org/drawingml/2006/main" xmlns:r="http://schemas.openxmlformats.org/officeDocument/2006/relationships" xmlns:p="http://schemas.openxmlformats.org/presentationml/2006/main">
   <p:cSld>
     <p:spTree>
       <p:nvGrpSpPr>
@@ -10514,7 +10659,14 @@
         <p:cNvGrpSpPr/>
         <p:nvPr/>
       </p:nvGrpSpPr>
-      <p:grpSpPr/>
+      <p:grpSpPr>
+        <a:xfrm>
+          <a:off x="0" y="0"/>
+          <a:ext cx="0" cy="0"/>
+          <a:chOff x="0" y="0"/>
+          <a:chExt cx="0" cy="0"/>
+        </a:xfrm>
+      </p:grpSpPr>
       <p:sp>
         <p:nvSpPr>
           <p:cNvPr id="2" name="Rectangle 1"/>
@@ -10555,6 +10707,7 @@
           <a:lstStyle/>
           <a:p>
             <a:pPr algn="ctr"/>
+            <a:endParaRPr/>
           </a:p>
         </p:txBody>
       </p:sp>
@@ -10708,6 +10861,7 @@
           <a:lstStyle/>
           <a:p>
             <a:pPr algn="ctr"/>
+            <a:endParaRPr/>
           </a:p>
         </p:txBody>
       </p:sp>
@@ -10751,6 +10905,7 @@
           <a:lstStyle/>
           <a:p>
             <a:pPr algn="ctr"/>
+            <a:endParaRPr/>
           </a:p>
         </p:txBody>
       </p:sp>
@@ -10968,6 +11123,7 @@
           <a:lstStyle/>
           <a:p>
             <a:pPr algn="ctr"/>
+            <a:endParaRPr/>
           </a:p>
         </p:txBody>
       </p:sp>
@@ -11011,6 +11167,7 @@
           <a:lstStyle/>
           <a:p>
             <a:pPr algn="ctr"/>
+            <a:endParaRPr/>
           </a:p>
         </p:txBody>
       </p:sp>
@@ -11228,6 +11385,7 @@
           <a:lstStyle/>
           <a:p>
             <a:pPr algn="ctr"/>
+            <a:endParaRPr/>
           </a:p>
         </p:txBody>
       </p:sp>
@@ -11271,6 +11429,7 @@
           <a:lstStyle/>
           <a:p>
             <a:pPr algn="ctr"/>
+            <a:endParaRPr/>
           </a:p>
         </p:txBody>
       </p:sp>
@@ -11484,7 +11643,7 @@
           </a:fontRef>
         </p:style>
         <p:txBody>
-          <a:bodyPr rtlCol="0" anchor="ctr" wrap="square"/>
+          <a:bodyPr wrap="square" rtlCol="0" anchor="ctr"/>
           <a:lstStyle/>
           <a:p>
             <a:pPr algn="ctr">
@@ -11596,6 +11755,7 @@
           <a:lstStyle/>
           <a:p>
             <a:pPr algn="ctr"/>
+            <a:endParaRPr/>
           </a:p>
         </p:txBody>
       </p:sp>
@@ -11680,7 +11840,7 @@
 </file>
 
 <file path=ppt/slides/slide7.xml><?xml version="1.0" encoding="utf-8"?>
-<p:sld xmlns:a="http://schemas.openxmlformats.org/drawingml/2006/main" xmlns:p="http://schemas.openxmlformats.org/presentationml/2006/main" xmlns:r="http://schemas.openxmlformats.org/officeDocument/2006/relationships">
+<p:sld xmlns:a="http://schemas.openxmlformats.org/drawingml/2006/main" xmlns:r="http://schemas.openxmlformats.org/officeDocument/2006/relationships" xmlns:p="http://schemas.openxmlformats.org/presentationml/2006/main">
   <p:cSld>
     <p:spTree>
       <p:nvGrpSpPr>
@@ -11688,7 +11848,14 @@
         <p:cNvGrpSpPr/>
         <p:nvPr/>
       </p:nvGrpSpPr>
-      <p:grpSpPr/>
+      <p:grpSpPr>
+        <a:xfrm>
+          <a:off x="0" y="0"/>
+          <a:ext cx="0" cy="0"/>
+          <a:chOff x="0" y="0"/>
+          <a:chExt cx="0" cy="0"/>
+        </a:xfrm>
+      </p:grpSpPr>
       <p:sp>
         <p:nvSpPr>
           <p:cNvPr id="2" name="Rectangle 1"/>
@@ -11729,6 +11896,7 @@
           <a:lstStyle/>
           <a:p>
             <a:pPr algn="ctr"/>
+            <a:endParaRPr/>
           </a:p>
         </p:txBody>
       </p:sp>
@@ -11882,6 +12050,7 @@
           <a:lstStyle/>
           <a:p>
             <a:pPr algn="ctr"/>
+            <a:endParaRPr/>
           </a:p>
         </p:txBody>
       </p:sp>
@@ -11925,6 +12094,7 @@
           <a:lstStyle/>
           <a:p>
             <a:pPr algn="ctr"/>
+            <a:endParaRPr/>
           </a:p>
         </p:txBody>
       </p:sp>
@@ -12117,6 +12287,7 @@
           <a:lstStyle/>
           <a:p>
             <a:pPr algn="ctr"/>
+            <a:endParaRPr/>
           </a:p>
         </p:txBody>
       </p:sp>
@@ -12160,6 +12331,7 @@
           <a:lstStyle/>
           <a:p>
             <a:pPr algn="ctr"/>
+            <a:endParaRPr/>
           </a:p>
         </p:txBody>
       </p:sp>
@@ -12352,6 +12524,7 @@
           <a:lstStyle/>
           <a:p>
             <a:pPr algn="ctr"/>
+            <a:endParaRPr/>
           </a:p>
         </p:txBody>
       </p:sp>
@@ -12395,6 +12568,7 @@
           <a:lstStyle/>
           <a:p>
             <a:pPr algn="ctr"/>
+            <a:endParaRPr/>
           </a:p>
         </p:txBody>
       </p:sp>
@@ -12587,6 +12761,7 @@
           <a:lstStyle/>
           <a:p>
             <a:pPr algn="ctr"/>
+            <a:endParaRPr/>
           </a:p>
         </p:txBody>
       </p:sp>
@@ -12630,6 +12805,7 @@
           <a:lstStyle/>
           <a:p>
             <a:pPr algn="ctr"/>
+            <a:endParaRPr/>
           </a:p>
         </p:txBody>
       </p:sp>
@@ -12820,6 +12996,7 @@
           <a:lstStyle/>
           <a:p>
             <a:pPr algn="ctr"/>
+            <a:endParaRPr/>
           </a:p>
         </p:txBody>
       </p:sp>
@@ -12904,7 +13081,7 @@
 </file>
 
 <file path=ppt/slides/slide8.xml><?xml version="1.0" encoding="utf-8"?>
-<p:sld xmlns:a="http://schemas.openxmlformats.org/drawingml/2006/main" xmlns:p="http://schemas.openxmlformats.org/presentationml/2006/main" xmlns:r="http://schemas.openxmlformats.org/officeDocument/2006/relationships">
+<p:sld xmlns:a="http://schemas.openxmlformats.org/drawingml/2006/main" xmlns:r="http://schemas.openxmlformats.org/officeDocument/2006/relationships" xmlns:p="http://schemas.openxmlformats.org/presentationml/2006/main">
   <p:cSld>
     <p:spTree>
       <p:nvGrpSpPr>
@@ -12912,7 +13089,14 @@
         <p:cNvGrpSpPr/>
         <p:nvPr/>
       </p:nvGrpSpPr>
-      <p:grpSpPr/>
+      <p:grpSpPr>
+        <a:xfrm>
+          <a:off x="0" y="0"/>
+          <a:ext cx="0" cy="0"/>
+          <a:chOff x="0" y="0"/>
+          <a:chExt cx="0" cy="0"/>
+        </a:xfrm>
+      </p:grpSpPr>
       <p:sp>
         <p:nvSpPr>
           <p:cNvPr id="2" name="Rectangle 1"/>
@@ -12953,6 +13137,7 @@
           <a:lstStyle/>
           <a:p>
             <a:pPr algn="ctr"/>
+            <a:endParaRPr/>
           </a:p>
         </p:txBody>
       </p:sp>
@@ -13106,6 +13291,7 @@
           <a:lstStyle/>
           <a:p>
             <a:pPr algn="ctr"/>
+            <a:endParaRPr/>
           </a:p>
         </p:txBody>
       </p:sp>
@@ -13149,6 +13335,7 @@
           <a:lstStyle/>
           <a:p>
             <a:pPr algn="ctr"/>
+            <a:endParaRPr/>
           </a:p>
         </p:txBody>
       </p:sp>
@@ -13259,6 +13446,7 @@
           <a:lstStyle/>
           <a:p>
             <a:pPr algn="ctr"/>
+            <a:endParaRPr/>
           </a:p>
         </p:txBody>
       </p:sp>
@@ -13302,6 +13490,7 @@
           <a:lstStyle/>
           <a:p>
             <a:pPr algn="ctr"/>
+            <a:endParaRPr/>
           </a:p>
         </p:txBody>
       </p:sp>
@@ -13412,6 +13601,7 @@
           <a:lstStyle/>
           <a:p>
             <a:pPr algn="ctr"/>
+            <a:endParaRPr/>
           </a:p>
         </p:txBody>
       </p:sp>
@@ -13455,6 +13645,7 @@
           <a:lstStyle/>
           <a:p>
             <a:pPr algn="ctr"/>
+            <a:endParaRPr/>
           </a:p>
         </p:txBody>
       </p:sp>
@@ -13565,6 +13756,7 @@
           <a:lstStyle/>
           <a:p>
             <a:pPr algn="ctr"/>
+            <a:endParaRPr/>
           </a:p>
         </p:txBody>
       </p:sp>
@@ -13608,6 +13800,7 @@
           <a:lstStyle/>
           <a:p>
             <a:pPr algn="ctr"/>
+            <a:endParaRPr/>
           </a:p>
         </p:txBody>
       </p:sp>
@@ -13718,6 +13911,7 @@
           <a:lstStyle/>
           <a:p>
             <a:pPr algn="ctr"/>
+            <a:endParaRPr/>
           </a:p>
         </p:txBody>
       </p:sp>
@@ -13761,6 +13955,7 @@
           <a:lstStyle/>
           <a:p>
             <a:pPr algn="ctr"/>
+            <a:endParaRPr/>
           </a:p>
         </p:txBody>
       </p:sp>
@@ -14003,6 +14198,7 @@
           <a:lstStyle/>
           <a:p>
             <a:pPr algn="ctr"/>
+            <a:endParaRPr/>
           </a:p>
         </p:txBody>
       </p:sp>
@@ -14046,6 +14242,7 @@
           <a:lstStyle/>
           <a:p>
             <a:pPr algn="ctr"/>
+            <a:endParaRPr/>
           </a:p>
         </p:txBody>
       </p:sp>
@@ -14261,6 +14458,7 @@
           <a:lstStyle/>
           <a:p>
             <a:pPr algn="ctr"/>
+            <a:endParaRPr/>
           </a:p>
         </p:txBody>
       </p:sp>
@@ -14345,7 +14543,7 @@
 </file>
 
 <file path=ppt/slides/slide9.xml><?xml version="1.0" encoding="utf-8"?>
-<p:sld xmlns:a="http://schemas.openxmlformats.org/drawingml/2006/main" xmlns:p="http://schemas.openxmlformats.org/presentationml/2006/main" xmlns:r="http://schemas.openxmlformats.org/officeDocument/2006/relationships">
+<p:sld xmlns:a="http://schemas.openxmlformats.org/drawingml/2006/main" xmlns:r="http://schemas.openxmlformats.org/officeDocument/2006/relationships" xmlns:p="http://schemas.openxmlformats.org/presentationml/2006/main">
   <p:cSld>
     <p:spTree>
       <p:nvGrpSpPr>
@@ -14353,7 +14551,14 @@
         <p:cNvGrpSpPr/>
         <p:nvPr/>
       </p:nvGrpSpPr>
-      <p:grpSpPr/>
+      <p:grpSpPr>
+        <a:xfrm>
+          <a:off x="0" y="0"/>
+          <a:ext cx="0" cy="0"/>
+          <a:chOff x="0" y="0"/>
+          <a:chExt cx="0" cy="0"/>
+        </a:xfrm>
+      </p:grpSpPr>
       <p:sp>
         <p:nvSpPr>
           <p:cNvPr id="2" name="Rectangle 1"/>
@@ -14394,6 +14599,7 @@
           <a:lstStyle/>
           <a:p>
             <a:pPr algn="ctr"/>
+            <a:endParaRPr/>
           </a:p>
         </p:txBody>
       </p:sp>
@@ -14547,6 +14753,7 @@
           <a:lstStyle/>
           <a:p>
             <a:pPr algn="ctr"/>
+            <a:endParaRPr/>
           </a:p>
         </p:txBody>
       </p:sp>
@@ -14590,6 +14797,7 @@
           <a:lstStyle/>
           <a:p>
             <a:pPr algn="ctr"/>
+            <a:endParaRPr/>
           </a:p>
         </p:txBody>
       </p:sp>
@@ -14832,6 +15040,7 @@
           <a:lstStyle/>
           <a:p>
             <a:pPr algn="ctr"/>
+            <a:endParaRPr/>
           </a:p>
         </p:txBody>
       </p:sp>
@@ -14875,6 +15084,7 @@
           <a:lstStyle/>
           <a:p>
             <a:pPr algn="ctr"/>
+            <a:endParaRPr/>
           </a:p>
         </p:txBody>
       </p:sp>
@@ -15117,6 +15327,7 @@
           <a:lstStyle/>
           <a:p>
             <a:pPr algn="ctr"/>
+            <a:endParaRPr/>
           </a:p>
         </p:txBody>
       </p:sp>
@@ -15160,6 +15371,7 @@
           <a:lstStyle/>
           <a:p>
             <a:pPr algn="ctr"/>
+            <a:endParaRPr/>
           </a:p>
         </p:txBody>
       </p:sp>
@@ -15398,7 +15610,7 @@
           </a:fontRef>
         </p:style>
         <p:txBody>
-          <a:bodyPr rtlCol="0" anchor="ctr" wrap="square"/>
+          <a:bodyPr wrap="square" rtlCol="0" anchor="ctr"/>
           <a:lstStyle/>
           <a:p>
             <a:pPr algn="ctr">
@@ -15495,6 +15707,7 @@
           <a:lstStyle/>
           <a:p>
             <a:pPr algn="ctr"/>
+            <a:endParaRPr/>
           </a:p>
         </p:txBody>
       </p:sp>

</xml_diff>